<commit_message>
Sunum: AUC/ölçüm slaytı çıkarıldı, defenses öncesine masking slaytı eklendi (8 slayt)
Co-Authored-By: Claude Sonnet 5.5 <noreply@anthropic.com>
</commit_message>
<xml_diff>
--- a/docs/sunum/presentation.pptx
+++ b/docs/sunum/presentation.pptx
@@ -1000,7 +1000,7 @@
           <a:lstStyle/>
           <a:p>
             <a:r>
-              <a:t>Measurement (55 s). The attacker is a simple fixed logistic-regression decoder that guesses, per topic, whether a confidential document exists. Leave-one-topic-out evaluation and randomized controls make sure the score is not memorization or luck. We report AUC because it needs no threshold, is not fooled by class imbalance and is one comparable number: it is the probability that a topic with a secret scores above one without. 0.5 is a coin flip, 1.0 perfect. We add TPR at one percent false positives, messages needed and leaked bits.</a:t>
+              <a:t>Findings (60 s). Under the weak ACL, gemma3's reply text lets the decoder tell secret topics apart: AUC 0.82, p 0.004. Behavior fields show no significant signal, and under the strong ACL nothing leaks. Masking topic words, numbers, names and 210 secret-only words did not reduce the signal (0.83 to 0.82): the signal is writing style. With confidential context the model uses we and our more, apologizes less and gives fewer contact details.</a:t>
             </a:r>
           </a:p>
         </p:txBody>
@@ -1070,7 +1070,7 @@
           <a:lstStyle/>
           <a:p>
             <a:r>
-              <a:t>Findings (60 s). Under the weak ACL, gemma3's reply text lets the decoder tell secret topics apart: AUC 0.82, p 0.004. Behavior fields show no significant signal, and under the strong ACL nothing leaks. Masking topic words, numbers, names and 210 secret-only words did not reduce the signal (0.83 to 0.82): the signal is writing style. With confidential context the model uses we and our more, apologizes less and gives fewer contact details.</a:t>
+              <a:t>Masking (55 s). Instead of dropping a confidential document, we keep it in the context but mask its sensitive parts just before the prompt is built. Oracle masking replaces a hand-listed set of secret spans; rule masking uses frozen regex rules for numbers, dates and names. Direct leakage drops from 0.50 to zero and utility stays near the undefended agent, unlike M2 whose resolution rate falls to 0.67. But the style channel stays open: AUC is 0.84 with oracle and 0.69 with rule masking, against 0.45 for M2, because a masked document still says that the topic exists.</a:t>
             </a:r>
           </a:p>
         </p:txBody>
@@ -6924,749 +6924,6 @@
                 </a:solidFill>
                 <a:latin typeface="Cambria"/>
               </a:rPr>
-              <a:t>Measurement: the decoder, and why AUC</a:t>
-            </a:r>
-          </a:p>
-        </p:txBody>
-      </p:sp>
-      <p:sp>
-        <p:nvSpPr>
-          <p:cNvPr id="4" name="Rounded Rectangle 3"/>
-          <p:cNvSpPr/>
-          <p:nvPr/>
-        </p:nvSpPr>
-        <p:spPr>
-          <a:xfrm>
-            <a:off x="731520" y="1325880"/>
-            <a:ext cx="5120640" cy="3108960"/>
-          </a:xfrm>
-          <a:prstGeom prst="roundRect">
-            <a:avLst>
-              <a:gd name="adj" fmla="val 6000"/>
-            </a:avLst>
-          </a:prstGeom>
-          <a:solidFill>
-            <a:srgbClr val="FFFFFF"/>
-          </a:solidFill>
-          <a:ln>
-            <a:noFill/>
-          </a:ln>
-          <a:effectLst/>
-        </p:spPr>
-        <p:style>
-          <a:lnRef idx="1">
-            <a:schemeClr val="accent1"/>
-          </a:lnRef>
-          <a:fillRef idx="3">
-            <a:schemeClr val="accent1"/>
-          </a:fillRef>
-          <a:effectRef idx="2">
-            <a:schemeClr val="accent1"/>
-          </a:effectRef>
-          <a:fontRef idx="minor">
-            <a:schemeClr val="lt1"/>
-          </a:fontRef>
-        </p:style>
-        <p:txBody>
-          <a:bodyPr rtlCol="0" anchor="t" wrap="square" lIns="164592" rIns="164592" tIns="91440" bIns="91440"/>
-          <a:lstStyle/>
-          <a:p>
-            <a:pPr algn="l">
-              <a:spcAft>
-                <a:spcPts val="600"/>
-              </a:spcAft>
-            </a:pPr>
-            <a:r>
-              <a:rPr sz="1800" b="1" i="0">
-                <a:solidFill>
-                  <a:srgbClr val="2B5C8F"/>
-                </a:solidFill>
-                <a:latin typeface="Calibri"/>
-              </a:rPr>
-              <a:t>Decoder (attacker model)</a:t>
-            </a:r>
-          </a:p>
-          <a:p>
-            <a:pPr algn="l">
-              <a:spcAft>
-                <a:spcPts val="600"/>
-              </a:spcAft>
-            </a:pPr>
-            <a:r>
-              <a:rPr sz="1400" b="0" i="0">
-                <a:solidFill>
-                  <a:srgbClr val="14212E"/>
-                </a:solidFill>
-                <a:latin typeface="Calibri"/>
-              </a:rPr>
-              <a:t>Features: behavior (escalation, refusal, routing, length, time) and text style (22 markers + embeddings).</a:t>
-            </a:r>
-          </a:p>
-          <a:p>
-            <a:pPr algn="l">
-              <a:spcAft>
-                <a:spcPts val="600"/>
-              </a:spcAft>
-            </a:pPr>
-            <a:r>
-              <a:rPr sz="1400" b="0" i="0">
-                <a:solidFill>
-                  <a:srgbClr val="14212E"/>
-                </a:solidFill>
-                <a:latin typeface="Calibri"/>
-              </a:rPr>
-              <a:t>Fixed L2 logistic regression, no tuning: a weak decoder that still succeeds proves the signal is real.</a:t>
-            </a:r>
-          </a:p>
-          <a:p>
-            <a:pPr algn="l">
-              <a:spcAft>
-                <a:spcPts val="600"/>
-              </a:spcAft>
-            </a:pPr>
-            <a:r>
-              <a:rPr sz="1400" b="0" i="0">
-                <a:solidFill>
-                  <a:srgbClr val="14212E"/>
-                </a:solidFill>
-                <a:latin typeface="Calibri"/>
-              </a:rPr>
-              <a:t>Leave-one-topic-out: train on 19 topics, test on the 20th.</a:t>
-            </a:r>
-          </a:p>
-          <a:p>
-            <a:pPr algn="l">
-              <a:spcAft>
-                <a:spcPts val="600"/>
-              </a:spcAft>
-            </a:pPr>
-            <a:r>
-              <a:rPr sz="1400" b="0" i="0">
-                <a:solidFill>
-                  <a:srgbClr val="14212E"/>
-                </a:solidFill>
-                <a:latin typeface="Calibri"/>
-              </a:rPr>
-              <a:t>Randomized controls: 500 label shuffles (p-value), row shuffle, placebo. “Open” = p &lt; 0.05 and CI above 0.5.</a:t>
-            </a:r>
-          </a:p>
-        </p:txBody>
-      </p:sp>
-      <p:sp>
-        <p:nvSpPr>
-          <p:cNvPr id="5" name="Rounded Rectangle 4"/>
-          <p:cNvSpPr/>
-          <p:nvPr/>
-        </p:nvSpPr>
-        <p:spPr>
-          <a:xfrm>
-            <a:off x="6080759" y="1325880"/>
-            <a:ext cx="5376672" cy="3108960"/>
-          </a:xfrm>
-          <a:prstGeom prst="roundRect">
-            <a:avLst>
-              <a:gd name="adj" fmla="val 6000"/>
-            </a:avLst>
-          </a:prstGeom>
-          <a:solidFill>
-            <a:srgbClr val="FFFFFF"/>
-          </a:solidFill>
-          <a:ln>
-            <a:noFill/>
-          </a:ln>
-          <a:effectLst/>
-        </p:spPr>
-        <p:style>
-          <a:lnRef idx="1">
-            <a:schemeClr val="accent1"/>
-          </a:lnRef>
-          <a:fillRef idx="3">
-            <a:schemeClr val="accent1"/>
-          </a:fillRef>
-          <a:effectRef idx="2">
-            <a:schemeClr val="accent1"/>
-          </a:effectRef>
-          <a:fontRef idx="minor">
-            <a:schemeClr val="lt1"/>
-          </a:fontRef>
-        </p:style>
-        <p:txBody>
-          <a:bodyPr rtlCol="0" anchor="t" wrap="square" lIns="164592" rIns="164592" tIns="91440" bIns="91440"/>
-          <a:lstStyle/>
-          <a:p>
-            <a:pPr algn="l">
-              <a:spcAft>
-                <a:spcPts val="600"/>
-              </a:spcAft>
-            </a:pPr>
-            <a:r>
-              <a:rPr sz="1800" b="1" i="0">
-                <a:solidFill>
-                  <a:srgbClr val="2B5C8F"/>
-                </a:solidFill>
-                <a:latin typeface="Calibri"/>
-              </a:rPr>
-              <a:t>AUC: area under the ROC curve</a:t>
-            </a:r>
-          </a:p>
-          <a:p>
-            <a:pPr algn="l">
-              <a:spcAft>
-                <a:spcPts val="600"/>
-              </a:spcAft>
-            </a:pPr>
-            <a:r>
-              <a:rPr sz="1400" b="0" i="0">
-                <a:solidFill>
-                  <a:srgbClr val="14212E"/>
-                </a:solidFill>
-                <a:latin typeface="Calibri"/>
-              </a:rPr>
-              <a:t>Probability that a topic </a:t>
-            </a:r>
-            <a:r>
-              <a:rPr sz="1400" b="1" i="0">
-                <a:solidFill>
-                  <a:srgbClr val="14212E"/>
-                </a:solidFill>
-                <a:latin typeface="Calibri"/>
-              </a:rPr>
-              <a:t>with</a:t>
-            </a:r>
-            <a:r>
-              <a:rPr sz="1400" b="0" i="0">
-                <a:solidFill>
-                  <a:srgbClr val="14212E"/>
-                </a:solidFill>
-                <a:latin typeface="Calibri"/>
-              </a:rPr>
-              <a:t> a secret scores higher than one </a:t>
-            </a:r>
-            <a:r>
-              <a:rPr sz="1400" b="1" i="0">
-                <a:solidFill>
-                  <a:srgbClr val="14212E"/>
-                </a:solidFill>
-                <a:latin typeface="Calibri"/>
-              </a:rPr>
-              <a:t>without</a:t>
-            </a:r>
-            <a:r>
-              <a:rPr sz="1400" b="0" i="0">
-                <a:solidFill>
-                  <a:srgbClr val="14212E"/>
-                </a:solidFill>
-                <a:latin typeface="Calibri"/>
-              </a:rPr>
-              <a:t>.</a:t>
-            </a:r>
-          </a:p>
-          <a:p>
-            <a:pPr algn="l">
-              <a:spcAft>
-                <a:spcPts val="600"/>
-              </a:spcAft>
-            </a:pPr>
-            <a:r>
-              <a:rPr sz="1400" b="0" i="0">
-                <a:solidFill>
-                  <a:srgbClr val="3B4A59"/>
-                </a:solidFill>
-                <a:latin typeface="Calibri"/>
-              </a:rPr>
-              <a:t>• No threshold needed.  • Robust to class imbalance.  • One comparable number.</a:t>
-            </a:r>
-          </a:p>
-        </p:txBody>
-      </p:sp>
-      <p:sp>
-        <p:nvSpPr>
-          <p:cNvPr id="6" name="Rectangle 5"/>
-          <p:cNvSpPr/>
-          <p:nvPr/>
-        </p:nvSpPr>
-        <p:spPr>
-          <a:xfrm>
-            <a:off x="6263640" y="3246120"/>
-            <a:ext cx="2468880" cy="292608"/>
-          </a:xfrm>
-          <a:prstGeom prst="rect">
-            <a:avLst/>
-          </a:prstGeom>
-          <a:solidFill>
-            <a:srgbClr val="E4E9EE"/>
-          </a:solidFill>
-          <a:ln>
-            <a:noFill/>
-          </a:ln>
-        </p:spPr>
-        <p:style>
-          <a:lnRef idx="1">
-            <a:schemeClr val="accent1"/>
-          </a:lnRef>
-          <a:fillRef idx="3">
-            <a:schemeClr val="accent1"/>
-          </a:fillRef>
-          <a:effectRef idx="2">
-            <a:schemeClr val="accent1"/>
-          </a:effectRef>
-          <a:fontRef idx="minor">
-            <a:schemeClr val="lt1"/>
-          </a:fontRef>
-        </p:style>
-        <p:txBody>
-          <a:bodyPr rtlCol="0" anchor="ctr"/>
-          <a:lstStyle/>
-          <a:p>
-            <a:pPr algn="ctr"/>
-          </a:p>
-        </p:txBody>
-      </p:sp>
-      <p:sp>
-        <p:nvSpPr>
-          <p:cNvPr id="7" name="Rectangle 6"/>
-          <p:cNvSpPr/>
-          <p:nvPr/>
-        </p:nvSpPr>
-        <p:spPr>
-          <a:xfrm>
-            <a:off x="8732520" y="3246120"/>
-            <a:ext cx="2468880" cy="292608"/>
-          </a:xfrm>
-          <a:prstGeom prst="rect">
-            <a:avLst/>
-          </a:prstGeom>
-          <a:solidFill>
-            <a:srgbClr val="F5D3BF"/>
-          </a:solidFill>
-          <a:ln>
-            <a:noFill/>
-          </a:ln>
-        </p:spPr>
-        <p:style>
-          <a:lnRef idx="1">
-            <a:schemeClr val="accent1"/>
-          </a:lnRef>
-          <a:fillRef idx="3">
-            <a:schemeClr val="accent1"/>
-          </a:fillRef>
-          <a:effectRef idx="2">
-            <a:schemeClr val="accent1"/>
-          </a:effectRef>
-          <a:fontRef idx="minor">
-            <a:schemeClr val="lt1"/>
-          </a:fontRef>
-        </p:style>
-        <p:txBody>
-          <a:bodyPr rtlCol="0" anchor="ctr"/>
-          <a:lstStyle/>
-          <a:p>
-            <a:pPr algn="ctr"/>
-          </a:p>
-        </p:txBody>
-      </p:sp>
-      <p:sp>
-        <p:nvSpPr>
-          <p:cNvPr id="8" name="TextBox 7"/>
-          <p:cNvSpPr txBox="1"/>
-          <p:nvPr/>
-        </p:nvSpPr>
-        <p:spPr>
-          <a:xfrm>
-            <a:off x="6263640" y="3584448"/>
-            <a:ext cx="2743200" cy="274320"/>
-          </a:xfrm>
-          <a:prstGeom prst="rect">
-            <a:avLst/>
-          </a:prstGeom>
-          <a:noFill/>
-        </p:spPr>
-        <p:txBody>
-          <a:bodyPr wrap="square" lIns="0" rIns="0" tIns="0" bIns="0" anchor="t">
-            <a:spAutoFit/>
-          </a:bodyPr>
-          <a:lstStyle/>
-          <a:p>
-            <a:pPr algn="l">
-              <a:spcAft>
-                <a:spcPts val="400"/>
-              </a:spcAft>
-            </a:pPr>
-            <a:r>
-              <a:rPr sz="1300" b="0" i="0">
-                <a:solidFill>
-                  <a:srgbClr val="566475"/>
-                </a:solidFill>
-                <a:latin typeface="Calibri"/>
-              </a:rPr>
-              <a:t>0.5 = coin flip</a:t>
-            </a:r>
-          </a:p>
-        </p:txBody>
-      </p:sp>
-      <p:sp>
-        <p:nvSpPr>
-          <p:cNvPr id="9" name="TextBox 8"/>
-          <p:cNvSpPr txBox="1"/>
-          <p:nvPr/>
-        </p:nvSpPr>
-        <p:spPr>
-          <a:xfrm>
-            <a:off x="8458200" y="3584448"/>
-            <a:ext cx="2743200" cy="274320"/>
-          </a:xfrm>
-          <a:prstGeom prst="rect">
-            <a:avLst/>
-          </a:prstGeom>
-          <a:noFill/>
-        </p:spPr>
-        <p:txBody>
-          <a:bodyPr wrap="square" lIns="0" rIns="0" tIns="0" bIns="0" anchor="t">
-            <a:spAutoFit/>
-          </a:bodyPr>
-          <a:lstStyle/>
-          <a:p>
-            <a:pPr algn="r">
-              <a:spcAft>
-                <a:spcPts val="400"/>
-              </a:spcAft>
-            </a:pPr>
-            <a:r>
-              <a:rPr sz="1300" b="0" i="0">
-                <a:solidFill>
-                  <a:srgbClr val="566475"/>
-                </a:solidFill>
-                <a:latin typeface="Calibri"/>
-              </a:rPr>
-              <a:t>1.0 = perfect</a:t>
-            </a:r>
-          </a:p>
-        </p:txBody>
-      </p:sp>
-      <p:sp>
-        <p:nvSpPr>
-          <p:cNvPr id="10" name="Rounded Rectangle 9"/>
-          <p:cNvSpPr/>
-          <p:nvPr/>
-        </p:nvSpPr>
-        <p:spPr>
-          <a:xfrm>
-            <a:off x="731520" y="4709160"/>
-            <a:ext cx="3422904" cy="1280160"/>
-          </a:xfrm>
-          <a:prstGeom prst="roundRect">
-            <a:avLst>
-              <a:gd name="adj" fmla="val 6000"/>
-            </a:avLst>
-          </a:prstGeom>
-          <a:solidFill>
-            <a:srgbClr val="FFFFFF"/>
-          </a:solidFill>
-          <a:ln>
-            <a:noFill/>
-          </a:ln>
-          <a:effectLst/>
-        </p:spPr>
-        <p:style>
-          <a:lnRef idx="1">
-            <a:schemeClr val="accent1"/>
-          </a:lnRef>
-          <a:fillRef idx="3">
-            <a:schemeClr val="accent1"/>
-          </a:fillRef>
-          <a:effectRef idx="2">
-            <a:schemeClr val="accent1"/>
-          </a:effectRef>
-          <a:fontRef idx="minor">
-            <a:schemeClr val="lt1"/>
-          </a:fontRef>
-        </p:style>
-        <p:txBody>
-          <a:bodyPr rtlCol="0" anchor="t" wrap="square" lIns="164592" rIns="164592" tIns="91440" bIns="91440"/>
-          <a:lstStyle/>
-          <a:p>
-            <a:pPr algn="l">
-              <a:spcAft>
-                <a:spcPts val="300"/>
-              </a:spcAft>
-            </a:pPr>
-            <a:r>
-              <a:rPr sz="1600" b="1" i="0">
-                <a:solidFill>
-                  <a:srgbClr val="14212E"/>
-                </a:solidFill>
-                <a:latin typeface="Calibri"/>
-              </a:rPr>
-              <a:t>TPR @ 1% FPR</a:t>
-            </a:r>
-          </a:p>
-          <a:p>
-            <a:pPr algn="l">
-              <a:spcAft>
-                <a:spcPts val="300"/>
-              </a:spcAft>
-            </a:pPr>
-            <a:r>
-              <a:rPr sz="1400" b="0" i="0">
-                <a:solidFill>
-                  <a:srgbClr val="566475"/>
-                </a:solidFill>
-                <a:latin typeface="Calibri"/>
-              </a:rPr>
-              <a:t>Secrets caught with only 1% false alarms.</a:t>
-            </a:r>
-          </a:p>
-        </p:txBody>
-      </p:sp>
-      <p:sp>
-        <p:nvSpPr>
-          <p:cNvPr id="11" name="Rounded Rectangle 10"/>
-          <p:cNvSpPr/>
-          <p:nvPr/>
-        </p:nvSpPr>
-        <p:spPr>
-          <a:xfrm>
-            <a:off x="4383024" y="4709160"/>
-            <a:ext cx="3422904" cy="1280160"/>
-          </a:xfrm>
-          <a:prstGeom prst="roundRect">
-            <a:avLst>
-              <a:gd name="adj" fmla="val 6000"/>
-            </a:avLst>
-          </a:prstGeom>
-          <a:solidFill>
-            <a:srgbClr val="FFFFFF"/>
-          </a:solidFill>
-          <a:ln>
-            <a:noFill/>
-          </a:ln>
-          <a:effectLst/>
-        </p:spPr>
-        <p:style>
-          <a:lnRef idx="1">
-            <a:schemeClr val="accent1"/>
-          </a:lnRef>
-          <a:fillRef idx="3">
-            <a:schemeClr val="accent1"/>
-          </a:fillRef>
-          <a:effectRef idx="2">
-            <a:schemeClr val="accent1"/>
-          </a:effectRef>
-          <a:fontRef idx="minor">
-            <a:schemeClr val="lt1"/>
-          </a:fontRef>
-        </p:style>
-        <p:txBody>
-          <a:bodyPr rtlCol="0" anchor="t" wrap="square" lIns="164592" rIns="164592" tIns="91440" bIns="91440"/>
-          <a:lstStyle/>
-          <a:p>
-            <a:pPr algn="l">
-              <a:spcAft>
-                <a:spcPts val="300"/>
-              </a:spcAft>
-            </a:pPr>
-            <a:r>
-              <a:rPr sz="1600" b="1" i="0">
-                <a:solidFill>
-                  <a:srgbClr val="14212E"/>
-                </a:solidFill>
-                <a:latin typeface="Calibri"/>
-              </a:rPr>
-              <a:t>Messages needed</a:t>
-            </a:r>
-          </a:p>
-          <a:p>
-            <a:pPr algn="l">
-              <a:spcAft>
-                <a:spcPts val="300"/>
-              </a:spcAft>
-            </a:pPr>
-            <a:r>
-              <a:rPr sz="1400" b="0" i="0">
-                <a:solidFill>
-                  <a:srgbClr val="566475"/>
-                </a:solidFill>
-                <a:latin typeface="Calibri"/>
-              </a:rPr>
-              <a:t>Probes until topic-level AUC reaches 0.9.</a:t>
-            </a:r>
-          </a:p>
-        </p:txBody>
-      </p:sp>
-      <p:sp>
-        <p:nvSpPr>
-          <p:cNvPr id="12" name="Rounded Rectangle 11"/>
-          <p:cNvSpPr/>
-          <p:nvPr/>
-        </p:nvSpPr>
-        <p:spPr>
-          <a:xfrm>
-            <a:off x="8034528" y="4709160"/>
-            <a:ext cx="3422904" cy="1280160"/>
-          </a:xfrm>
-          <a:prstGeom prst="roundRect">
-            <a:avLst>
-              <a:gd name="adj" fmla="val 6000"/>
-            </a:avLst>
-          </a:prstGeom>
-          <a:solidFill>
-            <a:srgbClr val="FFFFFF"/>
-          </a:solidFill>
-          <a:ln>
-            <a:noFill/>
-          </a:ln>
-          <a:effectLst/>
-        </p:spPr>
-        <p:style>
-          <a:lnRef idx="1">
-            <a:schemeClr val="accent1"/>
-          </a:lnRef>
-          <a:fillRef idx="3">
-            <a:schemeClr val="accent1"/>
-          </a:fillRef>
-          <a:effectRef idx="2">
-            <a:schemeClr val="accent1"/>
-          </a:effectRef>
-          <a:fontRef idx="minor">
-            <a:schemeClr val="lt1"/>
-          </a:fontRef>
-        </p:style>
-        <p:txBody>
-          <a:bodyPr rtlCol="0" anchor="t" wrap="square" lIns="164592" rIns="164592" tIns="91440" bIns="91440"/>
-          <a:lstStyle/>
-          <a:p>
-            <a:pPr algn="l">
-              <a:spcAft>
-                <a:spcPts val="300"/>
-              </a:spcAft>
-            </a:pPr>
-            <a:r>
-              <a:rPr sz="1600" b="1" i="0">
-                <a:solidFill>
-                  <a:srgbClr val="14212E"/>
-                </a:solidFill>
-                <a:latin typeface="Calibri"/>
-              </a:rPr>
-              <a:t>Leaked bits</a:t>
-            </a:r>
-          </a:p>
-          <a:p>
-            <a:pPr algn="l">
-              <a:spcAft>
-                <a:spcPts val="300"/>
-              </a:spcAft>
-            </a:pPr>
-            <a:r>
-              <a:rPr sz="1400" b="0" i="0">
-                <a:solidFill>
-                  <a:srgbClr val="566475"/>
-                </a:solidFill>
-                <a:latin typeface="Calibri"/>
-              </a:rPr>
-              <a:t>Information per message, in bits.</a:t>
-            </a:r>
-          </a:p>
-        </p:txBody>
-      </p:sp>
-    </p:spTree>
-  </p:cSld>
-  <p:clrMapOvr>
-    <a:masterClrMapping/>
-  </p:clrMapOvr>
-</p:sld>
-</file>
-
-<file path=ppt/slides/slide6.xml><?xml version="1.0" encoding="utf-8"?>
-<p:sld xmlns:a="http://schemas.openxmlformats.org/drawingml/2006/main" xmlns:p="http://schemas.openxmlformats.org/presentationml/2006/main" xmlns:r="http://schemas.openxmlformats.org/officeDocument/2006/relationships">
-  <p:cSld>
-    <p:bg>
-      <p:bgPr>
-        <a:solidFill>
-          <a:srgbClr val="F3F5F7"/>
-        </a:solidFill>
-        <a:effectLst/>
-      </p:bgPr>
-    </p:bg>
-    <p:spTree>
-      <p:nvGrpSpPr>
-        <p:cNvPr id="1" name=""/>
-        <p:cNvGrpSpPr/>
-        <p:nvPr/>
-      </p:nvGrpSpPr>
-      <p:grpSpPr/>
-      <p:sp>
-        <p:nvSpPr>
-          <p:cNvPr id="2" name="TextBox 1"/>
-          <p:cNvSpPr txBox="1"/>
-          <p:nvPr/>
-        </p:nvSpPr>
-        <p:spPr>
-          <a:xfrm>
-            <a:off x="731520" y="6355080"/>
-            <a:ext cx="7315200" cy="274320"/>
-          </a:xfrm>
-          <a:prstGeom prst="rect">
-            <a:avLst/>
-          </a:prstGeom>
-          <a:noFill/>
-        </p:spPr>
-        <p:txBody>
-          <a:bodyPr wrap="square" lIns="0" rIns="0" tIns="0" bIns="0" anchor="t">
-            <a:spAutoFit/>
-          </a:bodyPr>
-          <a:lstStyle/>
-          <a:p>
-            <a:pPr algn="l">
-              <a:spcAft>
-                <a:spcPts val="400"/>
-              </a:spcAft>
-            </a:pPr>
-            <a:r>
-              <a:rPr sz="1200" b="0" i="0">
-                <a:solidFill>
-                  <a:srgbClr val="566475"/>
-                </a:solidFill>
-                <a:latin typeface="Calibri"/>
-              </a:rPr>
-              <a:t>BLG558E · Security &amp; Privacy · Final Project</a:t>
-            </a:r>
-          </a:p>
-        </p:txBody>
-      </p:sp>
-      <p:sp>
-        <p:nvSpPr>
-          <p:cNvPr id="3" name="TextBox 2"/>
-          <p:cNvSpPr txBox="1"/>
-          <p:nvPr/>
-        </p:nvSpPr>
-        <p:spPr>
-          <a:xfrm>
-            <a:off x="731520" y="384048"/>
-            <a:ext cx="10725912" cy="822960"/>
-          </a:xfrm>
-          <a:prstGeom prst="rect">
-            <a:avLst/>
-          </a:prstGeom>
-          <a:noFill/>
-        </p:spPr>
-        <p:txBody>
-          <a:bodyPr wrap="square" lIns="0" rIns="0" tIns="0" bIns="0" anchor="ctr">
-            <a:spAutoFit/>
-          </a:bodyPr>
-          <a:lstStyle/>
-          <a:p>
-            <a:pPr algn="l">
-              <a:spcAft>
-                <a:spcPts val="400"/>
-              </a:spcAft>
-            </a:pPr>
-            <a:r>
-              <a:rPr sz="2800" b="1" i="0">
-                <a:solidFill>
-                  <a:srgbClr val="14212E"/>
-                </a:solidFill>
-                <a:latin typeface="Cambria"/>
-              </a:rPr>
               <a:t>Findings: reply style gives the topic away</a:t>
             </a:r>
           </a:p>
@@ -7724,7 +6981,7 @@
                 </a:solidFill>
                 <a:latin typeface="Calibri"/>
               </a:rPr>
-              <a:t>AUC; 0.5 = coin flip. Red = open, green = closed (strong ACL).</a:t>
+              <a:t>AUC = chance that a topic with a secret outranks one without; 0.5 = coin flip. Red = open, green = closed.</a:t>
             </a:r>
           </a:p>
         </p:txBody>
@@ -8187,8 +7444,8 @@
         </p:nvSpPr>
         <p:spPr>
           <a:xfrm>
-            <a:off x="731520" y="5212080"/>
-            <a:ext cx="10725912" cy="868680"/>
+            <a:off x="731520" y="5349240"/>
+            <a:ext cx="10725912" cy="777240"/>
           </a:xfrm>
           <a:prstGeom prst="roundRect">
             <a:avLst>
@@ -8243,6 +7500,1192 @@
                 <a:latin typeface="Calibri"/>
               </a:rPr>
               <a:t>(escalation, refusal, routing) show no significant signal; the agent rarely escalates or refuses. Under M2 nothing leaks.</a:t>
+            </a:r>
+          </a:p>
+        </p:txBody>
+      </p:sp>
+    </p:spTree>
+  </p:cSld>
+  <p:clrMapOvr>
+    <a:masterClrMapping/>
+  </p:clrMapOvr>
+</p:sld>
+</file>
+
+<file path=ppt/slides/slide6.xml><?xml version="1.0" encoding="utf-8"?>
+<p:sld xmlns:a="http://schemas.openxmlformats.org/drawingml/2006/main" xmlns:p="http://schemas.openxmlformats.org/presentationml/2006/main" xmlns:r="http://schemas.openxmlformats.org/officeDocument/2006/relationships">
+  <p:cSld>
+    <p:bg>
+      <p:bgPr>
+        <a:solidFill>
+          <a:srgbClr val="F3F5F7"/>
+        </a:solidFill>
+        <a:effectLst/>
+      </p:bgPr>
+    </p:bg>
+    <p:spTree>
+      <p:nvGrpSpPr>
+        <p:cNvPr id="1" name=""/>
+        <p:cNvGrpSpPr/>
+        <p:nvPr/>
+      </p:nvGrpSpPr>
+      <p:grpSpPr/>
+      <p:sp>
+        <p:nvSpPr>
+          <p:cNvPr id="2" name="TextBox 1"/>
+          <p:cNvSpPr txBox="1"/>
+          <p:nvPr/>
+        </p:nvSpPr>
+        <p:spPr>
+          <a:xfrm>
+            <a:off x="731520" y="6355080"/>
+            <a:ext cx="7315200" cy="274320"/>
+          </a:xfrm>
+          <a:prstGeom prst="rect">
+            <a:avLst/>
+          </a:prstGeom>
+          <a:noFill/>
+        </p:spPr>
+        <p:txBody>
+          <a:bodyPr wrap="square" lIns="0" rIns="0" tIns="0" bIns="0" anchor="t">
+            <a:spAutoFit/>
+          </a:bodyPr>
+          <a:lstStyle/>
+          <a:p>
+            <a:pPr algn="l">
+              <a:spcAft>
+                <a:spcPts val="400"/>
+              </a:spcAft>
+            </a:pPr>
+            <a:r>
+              <a:rPr sz="1200" b="0" i="0">
+                <a:solidFill>
+                  <a:srgbClr val="566475"/>
+                </a:solidFill>
+                <a:latin typeface="Calibri"/>
+              </a:rPr>
+              <a:t>BLG558E · Security &amp; Privacy · Final Project</a:t>
+            </a:r>
+          </a:p>
+        </p:txBody>
+      </p:sp>
+      <p:sp>
+        <p:nvSpPr>
+          <p:cNvPr id="3" name="TextBox 2"/>
+          <p:cNvSpPr txBox="1"/>
+          <p:nvPr/>
+        </p:nvSpPr>
+        <p:spPr>
+          <a:xfrm>
+            <a:off x="731520" y="384048"/>
+            <a:ext cx="10725912" cy="822960"/>
+          </a:xfrm>
+          <a:prstGeom prst="rect">
+            <a:avLst/>
+          </a:prstGeom>
+          <a:noFill/>
+        </p:spPr>
+        <p:txBody>
+          <a:bodyPr wrap="square" lIns="0" rIns="0" tIns="0" bIns="0" anchor="ctr">
+            <a:spAutoFit/>
+          </a:bodyPr>
+          <a:lstStyle/>
+          <a:p>
+            <a:pPr algn="l">
+              <a:spcAft>
+                <a:spcPts val="400"/>
+              </a:spcAft>
+            </a:pPr>
+            <a:r>
+              <a:rPr sz="2800" b="1" i="0">
+                <a:solidFill>
+                  <a:srgbClr val="14212E"/>
+                </a:solidFill>
+                <a:latin typeface="Cambria"/>
+              </a:rPr>
+              <a:t>Masking: keep the document, hide the details</a:t>
+            </a:r>
+          </a:p>
+        </p:txBody>
+      </p:sp>
+      <p:sp>
+        <p:nvSpPr>
+          <p:cNvPr id="4" name="Rounded Rectangle 3"/>
+          <p:cNvSpPr/>
+          <p:nvPr/>
+        </p:nvSpPr>
+        <p:spPr>
+          <a:xfrm>
+            <a:off x="731520" y="1325880"/>
+            <a:ext cx="2926080" cy="868680"/>
+          </a:xfrm>
+          <a:prstGeom prst="roundRect">
+            <a:avLst>
+              <a:gd name="adj" fmla="val 6000"/>
+            </a:avLst>
+          </a:prstGeom>
+          <a:solidFill>
+            <a:srgbClr val="FFFFFF"/>
+          </a:solidFill>
+          <a:ln w="15875">
+            <a:solidFill>
+              <a:srgbClr val="CBD5DF"/>
+            </a:solidFill>
+          </a:ln>
+          <a:effectLst/>
+        </p:spPr>
+        <p:style>
+          <a:lnRef idx="1">
+            <a:schemeClr val="accent1"/>
+          </a:lnRef>
+          <a:fillRef idx="3">
+            <a:schemeClr val="accent1"/>
+          </a:fillRef>
+          <a:effectRef idx="2">
+            <a:schemeClr val="accent1"/>
+          </a:effectRef>
+          <a:fontRef idx="minor">
+            <a:schemeClr val="lt1"/>
+          </a:fontRef>
+        </p:style>
+        <p:txBody>
+          <a:bodyPr rtlCol="0" anchor="t" wrap="square" lIns="164592" rIns="164592" tIns="91440" bIns="91440"/>
+          <a:lstStyle/>
+          <a:p>
+            <a:pPr algn="l">
+              <a:spcAft>
+                <a:spcPts val="200"/>
+              </a:spcAft>
+            </a:pPr>
+            <a:r>
+              <a:rPr sz="1600" b="1" i="0">
+                <a:solidFill>
+                  <a:srgbClr val="14212E"/>
+                </a:solidFill>
+                <a:latin typeface="Calibri"/>
+              </a:rPr>
+              <a:t>Search (M1)</a:t>
+            </a:r>
+          </a:p>
+          <a:p>
+            <a:pPr algn="l">
+              <a:spcAft>
+                <a:spcPts val="200"/>
+              </a:spcAft>
+            </a:pPr>
+            <a:r>
+              <a:rPr sz="1400" b="0" i="0">
+                <a:solidFill>
+                  <a:srgbClr val="566475"/>
+                </a:solidFill>
+                <a:latin typeface="Calibri"/>
+              </a:rPr>
+              <a:t>top-5, confidential included</a:t>
+            </a:r>
+          </a:p>
+        </p:txBody>
+      </p:sp>
+      <p:sp>
+        <p:nvSpPr>
+          <p:cNvPr id="5" name="TextBox 4"/>
+          <p:cNvSpPr txBox="1"/>
+          <p:nvPr/>
+        </p:nvSpPr>
+        <p:spPr>
+          <a:xfrm>
+            <a:off x="3657600" y="1508760"/>
+            <a:ext cx="411480" cy="457200"/>
+          </a:xfrm>
+          <a:prstGeom prst="rect">
+            <a:avLst/>
+          </a:prstGeom>
+          <a:noFill/>
+        </p:spPr>
+        <p:txBody>
+          <a:bodyPr wrap="square" lIns="0" rIns="0" tIns="0" bIns="0" anchor="ctr">
+            <a:spAutoFit/>
+          </a:bodyPr>
+          <a:lstStyle/>
+          <a:p>
+            <a:pPr algn="ctr">
+              <a:spcAft>
+                <a:spcPts val="400"/>
+              </a:spcAft>
+            </a:pPr>
+            <a:r>
+              <a:rPr sz="2800" b="1" i="0">
+                <a:solidFill>
+                  <a:srgbClr val="566475"/>
+                </a:solidFill>
+                <a:latin typeface="Calibri"/>
+              </a:rPr>
+              <a:t>→</a:t>
+            </a:r>
+          </a:p>
+        </p:txBody>
+      </p:sp>
+      <p:sp>
+        <p:nvSpPr>
+          <p:cNvPr id="6" name="Rounded Rectangle 5"/>
+          <p:cNvSpPr/>
+          <p:nvPr/>
+        </p:nvSpPr>
+        <p:spPr>
+          <a:xfrm>
+            <a:off x="4069080" y="1325880"/>
+            <a:ext cx="3566160" cy="868680"/>
+          </a:xfrm>
+          <a:prstGeom prst="roundRect">
+            <a:avLst>
+              <a:gd name="adj" fmla="val 6000"/>
+            </a:avLst>
+          </a:prstGeom>
+          <a:solidFill>
+            <a:srgbClr val="FFF4D6"/>
+          </a:solidFill>
+          <a:ln w="15875">
+            <a:solidFill>
+              <a:srgbClr val="B7791F"/>
+            </a:solidFill>
+          </a:ln>
+          <a:effectLst/>
+        </p:spPr>
+        <p:style>
+          <a:lnRef idx="1">
+            <a:schemeClr val="accent1"/>
+          </a:lnRef>
+          <a:fillRef idx="3">
+            <a:schemeClr val="accent1"/>
+          </a:fillRef>
+          <a:effectRef idx="2">
+            <a:schemeClr val="accent1"/>
+          </a:effectRef>
+          <a:fontRef idx="minor">
+            <a:schemeClr val="lt1"/>
+          </a:fontRef>
+        </p:style>
+        <p:txBody>
+          <a:bodyPr rtlCol="0" anchor="t" wrap="square" lIns="164592" rIns="164592" tIns="91440" bIns="91440"/>
+          <a:lstStyle/>
+          <a:p>
+            <a:pPr algn="l">
+              <a:spcAft>
+                <a:spcPts val="200"/>
+              </a:spcAft>
+            </a:pPr>
+            <a:r>
+              <a:rPr sz="1600" b="1" i="0">
+                <a:solidFill>
+                  <a:srgbClr val="14212E"/>
+                </a:solidFill>
+                <a:latin typeface="Calibri"/>
+              </a:rPr>
+              <a:t>Confidential chunk?</a:t>
+            </a:r>
+          </a:p>
+          <a:p>
+            <a:pPr algn="l">
+              <a:spcAft>
+                <a:spcPts val="200"/>
+              </a:spcAft>
+            </a:pPr>
+            <a:r>
+              <a:rPr sz="1400" b="0" i="0">
+                <a:solidFill>
+                  <a:srgbClr val="566475"/>
+                </a:solidFill>
+                <a:latin typeface="Calibri"/>
+              </a:rPr>
+              <a:t>yes → mask · no → keep</a:t>
+            </a:r>
+          </a:p>
+        </p:txBody>
+      </p:sp>
+      <p:sp>
+        <p:nvSpPr>
+          <p:cNvPr id="7" name="TextBox 6"/>
+          <p:cNvSpPr txBox="1"/>
+          <p:nvPr/>
+        </p:nvSpPr>
+        <p:spPr>
+          <a:xfrm>
+            <a:off x="7635240" y="1508760"/>
+            <a:ext cx="411480" cy="457200"/>
+          </a:xfrm>
+          <a:prstGeom prst="rect">
+            <a:avLst/>
+          </a:prstGeom>
+          <a:noFill/>
+        </p:spPr>
+        <p:txBody>
+          <a:bodyPr wrap="square" lIns="0" rIns="0" tIns="0" bIns="0" anchor="ctr">
+            <a:spAutoFit/>
+          </a:bodyPr>
+          <a:lstStyle/>
+          <a:p>
+            <a:pPr algn="ctr">
+              <a:spcAft>
+                <a:spcPts val="400"/>
+              </a:spcAft>
+            </a:pPr>
+            <a:r>
+              <a:rPr sz="2800" b="1" i="0">
+                <a:solidFill>
+                  <a:srgbClr val="566475"/>
+                </a:solidFill>
+                <a:latin typeface="Calibri"/>
+              </a:rPr>
+              <a:t>→</a:t>
+            </a:r>
+          </a:p>
+        </p:txBody>
+      </p:sp>
+      <p:sp>
+        <p:nvSpPr>
+          <p:cNvPr id="8" name="Rounded Rectangle 7"/>
+          <p:cNvSpPr/>
+          <p:nvPr/>
+        </p:nvSpPr>
+        <p:spPr>
+          <a:xfrm>
+            <a:off x="8046720" y="1325880"/>
+            <a:ext cx="2926080" cy="868680"/>
+          </a:xfrm>
+          <a:prstGeom prst="roundRect">
+            <a:avLst>
+              <a:gd name="adj" fmla="val 6000"/>
+            </a:avLst>
+          </a:prstGeom>
+          <a:solidFill>
+            <a:srgbClr val="FFFFFF"/>
+          </a:solidFill>
+          <a:ln w="15875">
+            <a:solidFill>
+              <a:srgbClr val="CBD5DF"/>
+            </a:solidFill>
+          </a:ln>
+          <a:effectLst/>
+        </p:spPr>
+        <p:style>
+          <a:lnRef idx="1">
+            <a:schemeClr val="accent1"/>
+          </a:lnRef>
+          <a:fillRef idx="3">
+            <a:schemeClr val="accent1"/>
+          </a:fillRef>
+          <a:effectRef idx="2">
+            <a:schemeClr val="accent1"/>
+          </a:effectRef>
+          <a:fontRef idx="minor">
+            <a:schemeClr val="lt1"/>
+          </a:fontRef>
+        </p:style>
+        <p:txBody>
+          <a:bodyPr rtlCol="0" anchor="t" wrap="square" lIns="164592" rIns="164592" tIns="91440" bIns="91440"/>
+          <a:lstStyle/>
+          <a:p>
+            <a:pPr algn="l">
+              <a:spcAft>
+                <a:spcPts val="200"/>
+              </a:spcAft>
+            </a:pPr>
+            <a:r>
+              <a:rPr sz="1600" b="1" i="0">
+                <a:solidFill>
+                  <a:srgbClr val="14212E"/>
+                </a:solidFill>
+                <a:latin typeface="Calibri"/>
+              </a:rPr>
+              <a:t>LLM</a:t>
+            </a:r>
+          </a:p>
+          <a:p>
+            <a:pPr algn="l">
+              <a:spcAft>
+                <a:spcPts val="200"/>
+              </a:spcAft>
+            </a:pPr>
+            <a:r>
+              <a:rPr sz="1400" b="0" i="0">
+                <a:solidFill>
+                  <a:srgbClr val="566475"/>
+                </a:solidFill>
+                <a:latin typeface="Calibri"/>
+              </a:rPr>
+              <a:t>sees masked text</a:t>
+            </a:r>
+          </a:p>
+        </p:txBody>
+      </p:sp>
+      <p:sp>
+        <p:nvSpPr>
+          <p:cNvPr id="9" name="Rounded Rectangle 8"/>
+          <p:cNvSpPr/>
+          <p:nvPr/>
+        </p:nvSpPr>
+        <p:spPr>
+          <a:xfrm>
+            <a:off x="731520" y="2377440"/>
+            <a:ext cx="10725912" cy="1005840"/>
+          </a:xfrm>
+          <a:prstGeom prst="roundRect">
+            <a:avLst>
+              <a:gd name="adj" fmla="val 6000"/>
+            </a:avLst>
+          </a:prstGeom>
+          <a:solidFill>
+            <a:srgbClr val="FFFFFF"/>
+          </a:solidFill>
+          <a:ln>
+            <a:noFill/>
+          </a:ln>
+          <a:effectLst/>
+        </p:spPr>
+        <p:style>
+          <a:lnRef idx="1">
+            <a:schemeClr val="accent1"/>
+          </a:lnRef>
+          <a:fillRef idx="3">
+            <a:schemeClr val="accent1"/>
+          </a:fillRef>
+          <a:effectRef idx="2">
+            <a:schemeClr val="accent1"/>
+          </a:effectRef>
+          <a:fontRef idx="minor">
+            <a:schemeClr val="lt1"/>
+          </a:fontRef>
+        </p:style>
+        <p:txBody>
+          <a:bodyPr rtlCol="0" anchor="ctr" wrap="square" lIns="164592" rIns="164592" tIns="91440" bIns="91440"/>
+          <a:lstStyle/>
+          <a:p>
+            <a:pPr algn="l">
+              <a:spcAft>
+                <a:spcPts val="200"/>
+              </a:spcAft>
+            </a:pPr>
+            <a:r>
+              <a:rPr sz="1300" b="0" i="0">
+                <a:solidFill>
+                  <a:srgbClr val="3B4A59"/>
+                </a:solidFill>
+                <a:latin typeface="Consolas"/>
+              </a:rPr>
+              <a:t>original: “… merger with Veltrix Holdings … board meets on the 24th.”</a:t>
+            </a:r>
+          </a:p>
+          <a:p>
+            <a:pPr algn="l">
+              <a:spcAft>
+                <a:spcPts val="200"/>
+              </a:spcAft>
+            </a:pPr>
+            <a:r>
+              <a:rPr sz="1300" b="0" i="0">
+                <a:solidFill>
+                  <a:srgbClr val="3B4A59"/>
+                </a:solidFill>
+                <a:latin typeface="Consolas"/>
+              </a:rPr>
+              <a:t>oracle:   “… merger with Veltrix Holdings … board meets on the [REDACTED].”</a:t>
+            </a:r>
+          </a:p>
+          <a:p>
+            <a:pPr algn="l">
+              <a:spcAft>
+                <a:spcPts val="200"/>
+              </a:spcAft>
+            </a:pPr>
+            <a:r>
+              <a:rPr sz="1300" b="0" i="0">
+                <a:solidFill>
+                  <a:srgbClr val="3B4A59"/>
+                </a:solidFill>
+                <a:latin typeface="Consolas"/>
+              </a:rPr>
+              <a:t>rule:     “… merger with [NAME] [NAME] … board meets on the [DATE].”</a:t>
+            </a:r>
+          </a:p>
+        </p:txBody>
+      </p:sp>
+      <p:graphicFrame>
+        <p:nvGraphicFramePr>
+          <p:cNvPr id="10" name="Table 9"/>
+          <p:cNvGraphicFramePr>
+            <a:graphicFrameLocks noGrp="1"/>
+          </p:cNvGraphicFramePr>
+          <p:nvPr/>
+        </p:nvGraphicFramePr>
+        <p:xfrm>
+          <a:off x="731520" y="3566160"/>
+          <a:ext cx="10725912" cy="1920240"/>
+        </p:xfrm>
+        <a:graphic>
+          <a:graphicData uri="http://schemas.openxmlformats.org/drawingml/2006/table">
+            <a:tbl>
+              <a:tblPr firstRow="0" bandRow="0">
+                <a:tableStyleId>{5C22544A-7EE6-4342-B048-85BDC9FD1C3A}</a:tableStyleId>
+              </a:tblPr>
+              <a:tblGrid>
+                <a:gridCol w="2743200"/>
+                <a:gridCol w="1828800"/>
+                <a:gridCol w="2194560"/>
+                <a:gridCol w="1828800"/>
+                <a:gridCol w="2130552"/>
+              </a:tblGrid>
+              <a:tr h="384048">
+                <a:tc>
+                  <a:txBody>
+                    <a:bodyPr wrap="square"/>
+                    <a:lstStyle/>
+                    <a:p>
+                      <a:pPr algn="l"/>
+                      <a:r>
+                        <a:rPr sz="1500" b="1">
+                          <a:solidFill>
+                            <a:srgbClr val="14212E"/>
+                          </a:solidFill>
+                          <a:latin typeface="Calibri"/>
+                        </a:rPr>
+                        <a:t>gemma3</a:t>
+                      </a:r>
+                    </a:p>
+                  </a:txBody>
+                  <a:tcPr marL="91440" marR="91440" marT="45720" marB="45720" anchor="ctr">
+                    <a:solidFill>
+                      <a:srgbClr val="E4E9EE"/>
+                    </a:solidFill>
+                  </a:tcPr>
+                </a:tc>
+                <a:tc>
+                  <a:txBody>
+                    <a:bodyPr wrap="square"/>
+                    <a:lstStyle/>
+                    <a:p>
+                      <a:pPr algn="r"/>
+                      <a:r>
+                        <a:rPr sz="1500" b="1">
+                          <a:solidFill>
+                            <a:srgbClr val="14212E"/>
+                          </a:solidFill>
+                          <a:latin typeface="Calibri"/>
+                        </a:rPr>
+                        <a:t>Text AUC</a:t>
+                      </a:r>
+                    </a:p>
+                  </a:txBody>
+                  <a:tcPr marL="91440" marR="91440" marT="45720" marB="45720" anchor="ctr">
+                    <a:solidFill>
+                      <a:srgbClr val="E4E9EE"/>
+                    </a:solidFill>
+                  </a:tcPr>
+                </a:tc>
+                <a:tc>
+                  <a:txBody>
+                    <a:bodyPr wrap="square"/>
+                    <a:lstStyle/>
+                    <a:p>
+                      <a:pPr algn="r"/>
+                      <a:r>
+                        <a:rPr sz="1500" b="1">
+                          <a:solidFill>
+                            <a:srgbClr val="14212E"/>
+                          </a:solidFill>
+                          <a:latin typeface="Calibri"/>
+                        </a:rPr>
+                        <a:t>Direct leakage</a:t>
+                      </a:r>
+                    </a:p>
+                  </a:txBody>
+                  <a:tcPr marL="91440" marR="91440" marT="45720" marB="45720" anchor="ctr">
+                    <a:solidFill>
+                      <a:srgbClr val="E4E9EE"/>
+                    </a:solidFill>
+                  </a:tcPr>
+                </a:tc>
+                <a:tc>
+                  <a:txBody>
+                    <a:bodyPr wrap="square"/>
+                    <a:lstStyle/>
+                    <a:p>
+                      <a:pPr algn="r"/>
+                      <a:r>
+                        <a:rPr sz="1500" b="1">
+                          <a:solidFill>
+                            <a:srgbClr val="14212E"/>
+                          </a:solidFill>
+                          <a:latin typeface="Calibri"/>
+                        </a:rPr>
+                        <a:t>Resolution</a:t>
+                      </a:r>
+                    </a:p>
+                  </a:txBody>
+                  <a:tcPr marL="91440" marR="91440" marT="45720" marB="45720" anchor="ctr">
+                    <a:solidFill>
+                      <a:srgbClr val="E4E9EE"/>
+                    </a:solidFill>
+                  </a:tcPr>
+                </a:tc>
+                <a:tc>
+                  <a:txBody>
+                    <a:bodyPr wrap="square"/>
+                    <a:lstStyle/>
+                    <a:p>
+                      <a:pPr algn="r"/>
+                      <a:r>
+                        <a:rPr sz="1500" b="1">
+                          <a:solidFill>
+                            <a:srgbClr val="14212E"/>
+                          </a:solidFill>
+                          <a:latin typeface="Calibri"/>
+                        </a:rPr>
+                        <a:t>Approved line</a:t>
+                      </a:r>
+                    </a:p>
+                  </a:txBody>
+                  <a:tcPr marL="91440" marR="91440" marT="45720" marB="45720" anchor="ctr">
+                    <a:solidFill>
+                      <a:srgbClr val="E4E9EE"/>
+                    </a:solidFill>
+                  </a:tcPr>
+                </a:tc>
+              </a:tr>
+              <a:tr h="384048">
+                <a:tc>
+                  <a:txBody>
+                    <a:bodyPr wrap="square"/>
+                    <a:lstStyle/>
+                    <a:p>
+                      <a:pPr algn="l"/>
+                      <a:r>
+                        <a:rPr sz="1500" b="0">
+                          <a:solidFill>
+                            <a:srgbClr val="14212E"/>
+                          </a:solidFill>
+                          <a:latin typeface="Calibri"/>
+                        </a:rPr>
+                        <a:t>M1 (none)</a:t>
+                      </a:r>
+                    </a:p>
+                  </a:txBody>
+                  <a:tcPr marL="91440" marR="91440" marT="45720" marB="45720" anchor="ctr">
+                    <a:solidFill>
+                      <a:srgbClr val="FFFFFF"/>
+                    </a:solidFill>
+                  </a:tcPr>
+                </a:tc>
+                <a:tc>
+                  <a:txBody>
+                    <a:bodyPr wrap="square"/>
+                    <a:lstStyle/>
+                    <a:p>
+                      <a:pPr algn="r"/>
+                      <a:r>
+                        <a:rPr sz="1500" b="1">
+                          <a:solidFill>
+                            <a:srgbClr val="C2410C"/>
+                          </a:solidFill>
+                          <a:latin typeface="Calibri"/>
+                        </a:rPr>
+                        <a:t>0.82</a:t>
+                      </a:r>
+                    </a:p>
+                  </a:txBody>
+                  <a:tcPr marL="91440" marR="91440" marT="45720" marB="45720" anchor="ctr">
+                    <a:solidFill>
+                      <a:srgbClr val="FFFFFF"/>
+                    </a:solidFill>
+                  </a:tcPr>
+                </a:tc>
+                <a:tc>
+                  <a:txBody>
+                    <a:bodyPr wrap="square"/>
+                    <a:lstStyle/>
+                    <a:p>
+                      <a:pPr algn="r"/>
+                      <a:r>
+                        <a:rPr sz="1500" b="1">
+                          <a:solidFill>
+                            <a:srgbClr val="C2410C"/>
+                          </a:solidFill>
+                          <a:latin typeface="Calibri"/>
+                        </a:rPr>
+                        <a:t>0.50</a:t>
+                      </a:r>
+                    </a:p>
+                  </a:txBody>
+                  <a:tcPr marL="91440" marR="91440" marT="45720" marB="45720" anchor="ctr">
+                    <a:solidFill>
+                      <a:srgbClr val="FFFFFF"/>
+                    </a:solidFill>
+                  </a:tcPr>
+                </a:tc>
+                <a:tc>
+                  <a:txBody>
+                    <a:bodyPr wrap="square"/>
+                    <a:lstStyle/>
+                    <a:p>
+                      <a:pPr algn="r"/>
+                      <a:r>
+                        <a:rPr sz="1500" b="0">
+                          <a:solidFill>
+                            <a:srgbClr val="14212E"/>
+                          </a:solidFill>
+                          <a:latin typeface="Calibri"/>
+                        </a:rPr>
+                        <a:t>0.92</a:t>
+                      </a:r>
+                    </a:p>
+                  </a:txBody>
+                  <a:tcPr marL="91440" marR="91440" marT="45720" marB="45720" anchor="ctr">
+                    <a:solidFill>
+                      <a:srgbClr val="FFFFFF"/>
+                    </a:solidFill>
+                  </a:tcPr>
+                </a:tc>
+                <a:tc>
+                  <a:txBody>
+                    <a:bodyPr wrap="square"/>
+                    <a:lstStyle/>
+                    <a:p>
+                      <a:pPr algn="r"/>
+                      <a:r>
+                        <a:rPr sz="1500" b="0">
+                          <a:solidFill>
+                            <a:srgbClr val="14212E"/>
+                          </a:solidFill>
+                          <a:latin typeface="Calibri"/>
+                        </a:rPr>
+                        <a:t>0.33</a:t>
+                      </a:r>
+                    </a:p>
+                  </a:txBody>
+                  <a:tcPr marL="91440" marR="91440" marT="45720" marB="45720" anchor="ctr">
+                    <a:solidFill>
+                      <a:srgbClr val="FFFFFF"/>
+                    </a:solidFill>
+                  </a:tcPr>
+                </a:tc>
+              </a:tr>
+              <a:tr h="384048">
+                <a:tc>
+                  <a:txBody>
+                    <a:bodyPr wrap="square"/>
+                    <a:lstStyle/>
+                    <a:p>
+                      <a:pPr algn="l"/>
+                      <a:r>
+                        <a:rPr sz="1500" b="0">
+                          <a:solidFill>
+                            <a:srgbClr val="14212E"/>
+                          </a:solidFill>
+                          <a:latin typeface="Calibri"/>
+                        </a:rPr>
+                        <a:t>M2</a:t>
+                      </a:r>
+                    </a:p>
+                  </a:txBody>
+                  <a:tcPr marL="91440" marR="91440" marT="45720" marB="45720" anchor="ctr">
+                    <a:solidFill>
+                      <a:srgbClr val="FFFFFF"/>
+                    </a:solidFill>
+                  </a:tcPr>
+                </a:tc>
+                <a:tc>
+                  <a:txBody>
+                    <a:bodyPr wrap="square"/>
+                    <a:lstStyle/>
+                    <a:p>
+                      <a:pPr algn="r"/>
+                      <a:r>
+                        <a:rPr sz="1500" b="1">
+                          <a:solidFill>
+                            <a:srgbClr val="17724F"/>
+                          </a:solidFill>
+                          <a:latin typeface="Calibri"/>
+                        </a:rPr>
+                        <a:t>0.45</a:t>
+                      </a:r>
+                    </a:p>
+                  </a:txBody>
+                  <a:tcPr marL="91440" marR="91440" marT="45720" marB="45720" anchor="ctr">
+                    <a:solidFill>
+                      <a:srgbClr val="FFFFFF"/>
+                    </a:solidFill>
+                  </a:tcPr>
+                </a:tc>
+                <a:tc>
+                  <a:txBody>
+                    <a:bodyPr wrap="square"/>
+                    <a:lstStyle/>
+                    <a:p>
+                      <a:pPr algn="r"/>
+                      <a:r>
+                        <a:rPr sz="1500" b="1">
+                          <a:solidFill>
+                            <a:srgbClr val="17724F"/>
+                          </a:solidFill>
+                          <a:latin typeface="Calibri"/>
+                        </a:rPr>
+                        <a:t>0.00</a:t>
+                      </a:r>
+                    </a:p>
+                  </a:txBody>
+                  <a:tcPr marL="91440" marR="91440" marT="45720" marB="45720" anchor="ctr">
+                    <a:solidFill>
+                      <a:srgbClr val="FFFFFF"/>
+                    </a:solidFill>
+                  </a:tcPr>
+                </a:tc>
+                <a:tc>
+                  <a:txBody>
+                    <a:bodyPr wrap="square"/>
+                    <a:lstStyle/>
+                    <a:p>
+                      <a:pPr algn="r"/>
+                      <a:r>
+                        <a:rPr sz="1500" b="1">
+                          <a:solidFill>
+                            <a:srgbClr val="C2410C"/>
+                          </a:solidFill>
+                          <a:latin typeface="Calibri"/>
+                        </a:rPr>
+                        <a:t>0.67</a:t>
+                      </a:r>
+                    </a:p>
+                  </a:txBody>
+                  <a:tcPr marL="91440" marR="91440" marT="45720" marB="45720" anchor="ctr">
+                    <a:solidFill>
+                      <a:srgbClr val="FFFFFF"/>
+                    </a:solidFill>
+                  </a:tcPr>
+                </a:tc>
+                <a:tc>
+                  <a:txBody>
+                    <a:bodyPr wrap="square"/>
+                    <a:lstStyle/>
+                    <a:p>
+                      <a:pPr algn="r"/>
+                      <a:r>
+                        <a:rPr sz="1500" b="1">
+                          <a:solidFill>
+                            <a:srgbClr val="C2410C"/>
+                          </a:solidFill>
+                          <a:latin typeface="Calibri"/>
+                        </a:rPr>
+                        <a:t>0.00</a:t>
+                      </a:r>
+                    </a:p>
+                  </a:txBody>
+                  <a:tcPr marL="91440" marR="91440" marT="45720" marB="45720" anchor="ctr">
+                    <a:solidFill>
+                      <a:srgbClr val="FFFFFF"/>
+                    </a:solidFill>
+                  </a:tcPr>
+                </a:tc>
+              </a:tr>
+              <a:tr h="384048">
+                <a:tc>
+                  <a:txBody>
+                    <a:bodyPr wrap="square"/>
+                    <a:lstStyle/>
+                    <a:p>
+                      <a:pPr algn="l"/>
+                      <a:r>
+                        <a:rPr sz="1500" b="0">
+                          <a:solidFill>
+                            <a:srgbClr val="14212E"/>
+                          </a:solidFill>
+                          <a:latin typeface="Calibri"/>
+                        </a:rPr>
+                        <a:t>mask · oracle</a:t>
+                      </a:r>
+                    </a:p>
+                  </a:txBody>
+                  <a:tcPr marL="91440" marR="91440" marT="45720" marB="45720" anchor="ctr">
+                    <a:solidFill>
+                      <a:srgbClr val="FFFFFF"/>
+                    </a:solidFill>
+                  </a:tcPr>
+                </a:tc>
+                <a:tc>
+                  <a:txBody>
+                    <a:bodyPr wrap="square"/>
+                    <a:lstStyle/>
+                    <a:p>
+                      <a:pPr algn="r"/>
+                      <a:r>
+                        <a:rPr sz="1500" b="1">
+                          <a:solidFill>
+                            <a:srgbClr val="C2410C"/>
+                          </a:solidFill>
+                          <a:latin typeface="Calibri"/>
+                        </a:rPr>
+                        <a:t>0.84</a:t>
+                      </a:r>
+                    </a:p>
+                  </a:txBody>
+                  <a:tcPr marL="91440" marR="91440" marT="45720" marB="45720" anchor="ctr">
+                    <a:solidFill>
+                      <a:srgbClr val="FFFFFF"/>
+                    </a:solidFill>
+                  </a:tcPr>
+                </a:tc>
+                <a:tc>
+                  <a:txBody>
+                    <a:bodyPr wrap="square"/>
+                    <a:lstStyle/>
+                    <a:p>
+                      <a:pPr algn="r"/>
+                      <a:r>
+                        <a:rPr sz="1500" b="1">
+                          <a:solidFill>
+                            <a:srgbClr val="17724F"/>
+                          </a:solidFill>
+                          <a:latin typeface="Calibri"/>
+                        </a:rPr>
+                        <a:t>0.00</a:t>
+                      </a:r>
+                    </a:p>
+                  </a:txBody>
+                  <a:tcPr marL="91440" marR="91440" marT="45720" marB="45720" anchor="ctr">
+                    <a:solidFill>
+                      <a:srgbClr val="FFFFFF"/>
+                    </a:solidFill>
+                  </a:tcPr>
+                </a:tc>
+                <a:tc>
+                  <a:txBody>
+                    <a:bodyPr wrap="square"/>
+                    <a:lstStyle/>
+                    <a:p>
+                      <a:pPr algn="r"/>
+                      <a:r>
+                        <a:rPr sz="1500" b="0">
+                          <a:solidFill>
+                            <a:srgbClr val="14212E"/>
+                          </a:solidFill>
+                          <a:latin typeface="Calibri"/>
+                        </a:rPr>
+                        <a:t>0.90</a:t>
+                      </a:r>
+                    </a:p>
+                  </a:txBody>
+                  <a:tcPr marL="91440" marR="91440" marT="45720" marB="45720" anchor="ctr">
+                    <a:solidFill>
+                      <a:srgbClr val="FFFFFF"/>
+                    </a:solidFill>
+                  </a:tcPr>
+                </a:tc>
+                <a:tc>
+                  <a:txBody>
+                    <a:bodyPr wrap="square"/>
+                    <a:lstStyle/>
+                    <a:p>
+                      <a:pPr algn="r"/>
+                      <a:r>
+                        <a:rPr sz="1500" b="0">
+                          <a:solidFill>
+                            <a:srgbClr val="14212E"/>
+                          </a:solidFill>
+                          <a:latin typeface="Calibri"/>
+                        </a:rPr>
+                        <a:t>0.33</a:t>
+                      </a:r>
+                    </a:p>
+                  </a:txBody>
+                  <a:tcPr marL="91440" marR="91440" marT="45720" marB="45720" anchor="ctr">
+                    <a:solidFill>
+                      <a:srgbClr val="FFFFFF"/>
+                    </a:solidFill>
+                  </a:tcPr>
+                </a:tc>
+              </a:tr>
+              <a:tr h="384048">
+                <a:tc>
+                  <a:txBody>
+                    <a:bodyPr wrap="square"/>
+                    <a:lstStyle/>
+                    <a:p>
+                      <a:pPr algn="l"/>
+                      <a:r>
+                        <a:rPr sz="1500" b="0">
+                          <a:solidFill>
+                            <a:srgbClr val="14212E"/>
+                          </a:solidFill>
+                          <a:latin typeface="Calibri"/>
+                        </a:rPr>
+                        <a:t>mask · rule</a:t>
+                      </a:r>
+                    </a:p>
+                  </a:txBody>
+                  <a:tcPr marL="91440" marR="91440" marT="45720" marB="45720" anchor="ctr">
+                    <a:solidFill>
+                      <a:srgbClr val="FFFFFF"/>
+                    </a:solidFill>
+                  </a:tcPr>
+                </a:tc>
+                <a:tc>
+                  <a:txBody>
+                    <a:bodyPr wrap="square"/>
+                    <a:lstStyle/>
+                    <a:p>
+                      <a:pPr algn="r"/>
+                      <a:r>
+                        <a:rPr sz="1500" b="1">
+                          <a:solidFill>
+                            <a:srgbClr val="C2410C"/>
+                          </a:solidFill>
+                          <a:latin typeface="Calibri"/>
+                        </a:rPr>
+                        <a:t>0.69</a:t>
+                      </a:r>
+                    </a:p>
+                  </a:txBody>
+                  <a:tcPr marL="91440" marR="91440" marT="45720" marB="45720" anchor="ctr">
+                    <a:solidFill>
+                      <a:srgbClr val="FFFFFF"/>
+                    </a:solidFill>
+                  </a:tcPr>
+                </a:tc>
+                <a:tc>
+                  <a:txBody>
+                    <a:bodyPr wrap="square"/>
+                    <a:lstStyle/>
+                    <a:p>
+                      <a:pPr algn="r"/>
+                      <a:r>
+                        <a:rPr sz="1500" b="1">
+                          <a:solidFill>
+                            <a:srgbClr val="17724F"/>
+                          </a:solidFill>
+                          <a:latin typeface="Calibri"/>
+                        </a:rPr>
+                        <a:t>0.00</a:t>
+                      </a:r>
+                    </a:p>
+                  </a:txBody>
+                  <a:tcPr marL="91440" marR="91440" marT="45720" marB="45720" anchor="ctr">
+                    <a:solidFill>
+                      <a:srgbClr val="FFFFFF"/>
+                    </a:solidFill>
+                  </a:tcPr>
+                </a:tc>
+                <a:tc>
+                  <a:txBody>
+                    <a:bodyPr wrap="square"/>
+                    <a:lstStyle/>
+                    <a:p>
+                      <a:pPr algn="r"/>
+                      <a:r>
+                        <a:rPr sz="1500" b="0">
+                          <a:solidFill>
+                            <a:srgbClr val="14212E"/>
+                          </a:solidFill>
+                          <a:latin typeface="Calibri"/>
+                        </a:rPr>
+                        <a:t>0.92</a:t>
+                      </a:r>
+                    </a:p>
+                  </a:txBody>
+                  <a:tcPr marL="91440" marR="91440" marT="45720" marB="45720" anchor="ctr">
+                    <a:solidFill>
+                      <a:srgbClr val="FFFFFF"/>
+                    </a:solidFill>
+                  </a:tcPr>
+                </a:tc>
+                <a:tc>
+                  <a:txBody>
+                    <a:bodyPr wrap="square"/>
+                    <a:lstStyle/>
+                    <a:p>
+                      <a:pPr algn="r"/>
+                      <a:r>
+                        <a:rPr sz="1500" b="0">
+                          <a:solidFill>
+                            <a:srgbClr val="14212E"/>
+                          </a:solidFill>
+                          <a:latin typeface="Calibri"/>
+                        </a:rPr>
+                        <a:t>0.39</a:t>
+                      </a:r>
+                    </a:p>
+                  </a:txBody>
+                  <a:tcPr marL="91440" marR="91440" marT="45720" marB="45720" anchor="ctr">
+                    <a:solidFill>
+                      <a:srgbClr val="FFFFFF"/>
+                    </a:solidFill>
+                  </a:tcPr>
+                </a:tc>
+              </a:tr>
+            </a:tbl>
+          </a:graphicData>
+        </a:graphic>
+      </p:graphicFrame>
+      <p:sp>
+        <p:nvSpPr>
+          <p:cNvPr id="11" name="Rounded Rectangle 10"/>
+          <p:cNvSpPr/>
+          <p:nvPr/>
+        </p:nvSpPr>
+        <p:spPr>
+          <a:xfrm>
+            <a:off x="731520" y="5577840"/>
+            <a:ext cx="10725912" cy="685800"/>
+          </a:xfrm>
+          <a:prstGeom prst="roundRect">
+            <a:avLst>
+              <a:gd name="adj" fmla="val 6000"/>
+            </a:avLst>
+          </a:prstGeom>
+          <a:solidFill>
+            <a:srgbClr val="E6EFF8"/>
+          </a:solidFill>
+          <a:ln>
+            <a:noFill/>
+          </a:ln>
+          <a:effectLst/>
+        </p:spPr>
+        <p:style>
+          <a:lnRef idx="1">
+            <a:schemeClr val="accent1"/>
+          </a:lnRef>
+          <a:fillRef idx="3">
+            <a:schemeClr val="accent1"/>
+          </a:fillRef>
+          <a:effectRef idx="2">
+            <a:schemeClr val="accent1"/>
+          </a:effectRef>
+          <a:fontRef idx="minor">
+            <a:schemeClr val="lt1"/>
+          </a:fontRef>
+        </p:style>
+        <p:txBody>
+          <a:bodyPr rtlCol="0" anchor="ctr" wrap="square" lIns="164592" rIns="164592" tIns="91440" bIns="91440"/>
+          <a:lstStyle/>
+          <a:p>
+            <a:pPr algn="l">
+              <a:spcAft>
+                <a:spcPts val="400"/>
+              </a:spcAft>
+            </a:pPr>
+            <a:r>
+              <a:rPr sz="1400" b="1" i="0">
+                <a:solidFill>
+                  <a:srgbClr val="14212E"/>
+                </a:solidFill>
+                <a:latin typeface="Calibri"/>
+              </a:rPr>
+              <a:t>Content leakage closed, utility kept; the topic’s existence still leaks. </a:t>
+            </a:r>
+            <a:r>
+              <a:rPr sz="1400" b="0" i="0">
+                <a:solidFill>
+                  <a:srgbClr val="14212E"/>
+                </a:solidFill>
+                <a:latin typeface="Calibri"/>
+              </a:rPr>
+              <a:t>“Approved line” = the agent says the officially approved sentence, e.g. “we do not comment on rumours”.</a:t>
             </a:r>
           </a:p>
         </p:txBody>

</xml_diff>

<commit_message>
Sunum 5. slayt: neden AUC kartı eklendi
Co-Authored-By: Claude Sonnet 5.5 <noreply@anthropic.com>
</commit_message>
<xml_diff>
--- a/docs/sunum/presentation.pptx
+++ b/docs/sunum/presentation.pptx
@@ -1000,7 +1000,7 @@
           <a:lstStyle/>
           <a:p>
             <a:r>
-              <a:t>Findings (60 s). Under the weak ACL, gemma3's reply text lets the decoder tell secret topics apart: AUC 0.82, p 0.004. Behavior fields show no significant signal, and under the strong ACL nothing leaks. Masking topic words, numbers, names and 210 secret-only words did not reduce the signal (0.83 to 0.82): the signal is writing style. With confidential context the model uses we and our more, apologizes less and gives fewer contact details.</a:t>
+              <a:t>Findings (60 s). Under the weak ACL, gemma3's reply text lets the decoder tell secret topics apart: AUC 0.82, p 0.004. Behavior fields show no significant signal, and under the strong ACL nothing leaks. Masking topic words, numbers, names and 210 secret-only words did not reduce the signal (0.83 to 0.82): the signal is writing style. We report AUC because it needs no threshold, is not fooled by class imbalance and gives one comparable number: the chance that a topic with a secret scores above one without; 0.5 is a coin flip. With confidential context the model uses we and our more, apologizes less and gives fewer contact details.</a:t>
             </a:r>
           </a:p>
         </p:txBody>
@@ -6939,7 +6939,7 @@
         </p:nvGraphicFramePr>
         <p:xfrm>
           <a:off x="731520" y="1280160"/>
-          <a:ext cx="5943600" cy="3566160"/>
+          <a:ext cx="5943600" cy="3017520"/>
         </p:xfrm>
         <a:graphic>
           <a:graphicData uri="http://schemas.openxmlformats.org/drawingml/2006/chart">
@@ -6955,7 +6955,7 @@
         </p:nvSpPr>
         <p:spPr>
           <a:xfrm>
-            <a:off x="731520" y="4873752"/>
+            <a:off x="731520" y="4343400"/>
             <a:ext cx="5943600" cy="274320"/>
           </a:xfrm>
           <a:prstGeom prst="rect">
@@ -6981,7 +6981,7 @@
                 </a:solidFill>
                 <a:latin typeface="Calibri"/>
               </a:rPr>
-              <a:t>AUC = chance that a topic with a secret outranks one without; 0.5 = coin flip. Red = open, green = closed.</a:t>
+              <a:t>AUC; 0.5 = coin flip. Red = open channel, green = closed.</a:t>
             </a:r>
           </a:p>
         </p:txBody>
@@ -7444,8 +7444,76 @@
         </p:nvSpPr>
         <p:spPr>
           <a:xfrm>
-            <a:off x="731520" y="5349240"/>
-            <a:ext cx="10725912" cy="777240"/>
+            <a:off x="731520" y="4892040"/>
+            <a:ext cx="5943600" cy="1280160"/>
+          </a:xfrm>
+          <a:prstGeom prst="roundRect">
+            <a:avLst>
+              <a:gd name="adj" fmla="val 6000"/>
+            </a:avLst>
+          </a:prstGeom>
+          <a:solidFill>
+            <a:srgbClr val="FFFFFF"/>
+          </a:solidFill>
+          <a:ln>
+            <a:noFill/>
+          </a:ln>
+          <a:effectLst/>
+        </p:spPr>
+        <p:style>
+          <a:lnRef idx="1">
+            <a:schemeClr val="accent1"/>
+          </a:lnRef>
+          <a:fillRef idx="3">
+            <a:schemeClr val="accent1"/>
+          </a:fillRef>
+          <a:effectRef idx="2">
+            <a:schemeClr val="accent1"/>
+          </a:effectRef>
+          <a:fontRef idx="minor">
+            <a:schemeClr val="lt1"/>
+          </a:fontRef>
+        </p:style>
+        <p:txBody>
+          <a:bodyPr rtlCol="0" anchor="ctr" wrap="square" lIns="164592" rIns="164592" tIns="91440" bIns="91440"/>
+          <a:lstStyle/>
+          <a:p>
+            <a:pPr algn="l">
+              <a:spcAft>
+                <a:spcPts val="400"/>
+              </a:spcAft>
+            </a:pPr>
+            <a:r>
+              <a:rPr sz="1500" b="1" i="0">
+                <a:solidFill>
+                  <a:srgbClr val="2B5C8F"/>
+                </a:solidFill>
+                <a:latin typeface="Calibri"/>
+              </a:rPr>
+              <a:t>Why AUC? </a:t>
+            </a:r>
+            <a:r>
+              <a:rPr sz="1400" b="0" i="0">
+                <a:solidFill>
+                  <a:srgbClr val="14212E"/>
+                </a:solidFill>
+                <a:latin typeface="Calibri"/>
+              </a:rPr>
+              <a:t>It is the chance that a topic with a secret scores above one without. It needs no threshold, is not fooled by class imbalance and gives one comparable number (0.5 = coin flip, 1.0 = perfect).</a:t>
+            </a:r>
+          </a:p>
+        </p:txBody>
+      </p:sp>
+      <p:sp>
+        <p:nvSpPr>
+          <p:cNvPr id="9" name="Rounded Rectangle 8"/>
+          <p:cNvSpPr/>
+          <p:nvPr/>
+        </p:nvSpPr>
+        <p:spPr>
+          <a:xfrm>
+            <a:off x="6903720" y="4892040"/>
+            <a:ext cx="4553712" cy="1280160"/>
           </a:xfrm>
           <a:prstGeom prst="roundRect">
             <a:avLst>
@@ -7493,7 +7561,7 @@
               <a:t>Behavior fields </a:t>
             </a:r>
             <a:r>
-              <a:rPr sz="1500" b="0" i="0">
+              <a:rPr sz="1400" b="0" i="0">
                 <a:solidFill>
                   <a:srgbClr val="14212E"/>
                 </a:solidFill>

</xml_diff>